<commit_message>
feat: Langfuse tracing + MPP benchmark + CTS audit + Terraform zero-diff
- Langfuse: API ingestion (us.cloud.langfuse.com), fix timestamp batch bug
- Demo script v3.1: EXPLAIN ANALYZE live, MPP window functions, CTS audit trail, Terraform zero-diff, 50min timing
- Terraform: lifecycle ignore_changes event_notification_name → permanent zero-diff
- Architecture: CTS node + KMS edge in drawio, Terraform IaC layer, 3-datanode MPP labels
- PPTs: Slide 2 regenerated with architecture diagram, executive deck badges updated
- Dashboard: DWS data alignment, 5-tab layout
- Prep checklist: 11 tabs (added CTS)
- Docs: architecture.md updated, workshop-handout.md added, GEMINI.md added
- Fixes: Makefile Python indent, DM view drop state column, cloud.langfuse.com→us.cloud.langfuse.com
</commit_message>
<xml_diff>
--- a/docs/ayco-executive-deck.pptx
+++ b/docs/ayco-executive-deck.pptx
@@ -1072,6 +1072,10 @@
           </a:solidFill>
           <a:ln/>
         </p:spPr>
+        <p:txBody>
+          <a:bodyPr/>
+          <a:p/>
+        </p:txBody>
       </p:sp>
       <p:sp>
         <p:nvSpPr>
@@ -1172,6 +1176,10 @@
           </a:solidFill>
           <a:ln/>
         </p:spPr>
+        <p:txBody>
+          <a:bodyPr/>
+          <a:p/>
+        </p:txBody>
       </p:sp>
       <p:sp>
         <p:nvSpPr>
@@ -1192,6 +1200,10 @@
           </a:solidFill>
           <a:ln/>
         </p:spPr>
+        <p:txBody>
+          <a:bodyPr/>
+          <a:p/>
+        </p:txBody>
       </p:sp>
       <p:sp>
         <p:nvSpPr>
@@ -1288,7 +1300,7 @@
                 <a:ea typeface="Segoe UI" pitchFamily="34" charset="-122"/>
                 <a:cs typeface="Segoe UI" pitchFamily="34" charset="-120"/>
               </a:rPr>
-              <a:t>y 11 containers</a:t>
+              <a:t>11 containers · MPP 3 datanodes · CTS audit · Terraform IaC</a:t>
             </a:r>
             <a:endParaRPr lang="en-US" sz="1000" dirty="0"/>
           </a:p>
@@ -1315,6 +1327,10 @@
           </a:solidFill>
           <a:ln/>
         </p:spPr>
+        <p:txBody>
+          <a:bodyPr/>
+          <a:p/>
+        </p:txBody>
       </p:sp>
       <p:sp>
         <p:nvSpPr>
@@ -1335,6 +1351,10 @@
           </a:solidFill>
           <a:ln/>
         </p:spPr>
+        <p:txBody>
+          <a:bodyPr/>
+          <a:p/>
+        </p:txBody>
       </p:sp>
       <p:sp>
         <p:nvSpPr>
@@ -1458,6 +1478,10 @@
           </a:solidFill>
           <a:ln/>
         </p:spPr>
+        <p:txBody>
+          <a:bodyPr/>
+          <a:p/>
+        </p:txBody>
       </p:sp>
       <p:sp>
         <p:nvSpPr>
@@ -1478,6 +1502,10 @@
           </a:solidFill>
           <a:ln/>
         </p:spPr>
+        <p:txBody>
+          <a:bodyPr/>
+          <a:p/>
+        </p:txBody>
       </p:sp>
       <p:sp>
         <p:nvSpPr>
@@ -1601,6 +1629,10 @@
           </a:solidFill>
           <a:ln/>
         </p:spPr>
+        <p:txBody>
+          <a:bodyPr/>
+          <a:p/>
+        </p:txBody>
       </p:sp>
       <p:sp>
         <p:nvSpPr>
@@ -1621,6 +1653,10 @@
           </a:solidFill>
           <a:ln/>
         </p:spPr>
+        <p:txBody>
+          <a:bodyPr/>
+          <a:p/>
+        </p:txBody>
       </p:sp>
       <p:sp>
         <p:nvSpPr>
@@ -1744,6 +1780,10 @@
           </a:solidFill>
           <a:ln/>
         </p:spPr>
+        <p:txBody>
+          <a:bodyPr/>
+          <a:p/>
+        </p:txBody>
       </p:sp>
       <p:sp>
         <p:nvSpPr>
@@ -1764,6 +1804,10 @@
           </a:solidFill>
           <a:ln/>
         </p:spPr>
+        <p:txBody>
+          <a:bodyPr/>
+          <a:p/>
+        </p:txBody>
       </p:sp>
       <p:sp>
         <p:nvSpPr>
@@ -1887,6 +1931,10 @@
           </a:solidFill>
           <a:ln/>
         </p:spPr>
+        <p:txBody>
+          <a:bodyPr/>
+          <a:p/>
+        </p:txBody>
       </p:sp>
       <p:sp>
         <p:nvSpPr>
@@ -1907,6 +1955,10 @@
           </a:solidFill>
           <a:ln/>
         </p:spPr>
+        <p:txBody>
+          <a:bodyPr/>
+          <a:p/>
+        </p:txBody>
       </p:sp>
       <p:sp>
         <p:nvSpPr>
@@ -2030,6 +2082,10 @@
           </a:solidFill>
           <a:ln/>
         </p:spPr>
+        <p:txBody>
+          <a:bodyPr/>
+          <a:p/>
+        </p:txBody>
       </p:sp>
       <p:sp>
         <p:nvSpPr>
@@ -2050,6 +2106,10 @@
           </a:solidFill>
           <a:ln/>
         </p:spPr>
+        <p:txBody>
+          <a:bodyPr/>
+          <a:p/>
+        </p:txBody>
       </p:sp>
       <p:sp>
         <p:nvSpPr>
@@ -2173,6 +2233,10 @@
           </a:solidFill>
           <a:ln/>
         </p:spPr>
+        <p:txBody>
+          <a:bodyPr/>
+          <a:p/>
+        </p:txBody>
       </p:sp>
       <p:sp>
         <p:nvSpPr>
@@ -2193,6 +2257,10 @@
           </a:solidFill>
           <a:ln/>
         </p:spPr>
+        <p:txBody>
+          <a:bodyPr/>
+          <a:p/>
+        </p:txBody>
       </p:sp>
       <p:sp>
         <p:nvSpPr>
@@ -2270,6 +2338,14 @@
                 <a:cs typeface="Segoe UI" pitchFamily="34" charset="-120"/>
               </a:rPr>
               <a:t>Governance</a:t>
+            </a:r>
+            <a:r>
+              <a:rPr sz="1000">
+                <a:solidFill>
+                  <a:srgbClr val="CCCCCC"/>
+                </a:solidFill>
+              </a:rPr>
+              <a:t> · CTS · Terraform</a:t>
             </a:r>
             <a:endParaRPr lang="en-US" sz="1000" dirty="0"/>
           </a:p>
@@ -3727,6 +3803,10 @@
           </a:solidFill>
           <a:ln/>
         </p:spPr>
+        <p:txBody>
+          <a:bodyPr/>
+          <a:p/>
+        </p:txBody>
       </p:sp>
       <p:sp>
         <p:nvSpPr>
@@ -3827,6 +3907,10 @@
           </a:solidFill>
           <a:ln/>
         </p:spPr>
+        <p:txBody>
+          <a:bodyPr/>
+          <a:p/>
+        </p:txBody>
       </p:sp>
       <p:sp>
         <p:nvSpPr>
@@ -3847,6 +3931,10 @@
           </a:solidFill>
           <a:ln/>
         </p:spPr>
+        <p:txBody>
+          <a:bodyPr/>
+          <a:p/>
+        </p:txBody>
       </p:sp>
       <p:sp>
         <p:nvSpPr>
@@ -4140,6 +4228,10 @@
           </a:solidFill>
           <a:ln/>
         </p:spPr>
+        <p:txBody>
+          <a:bodyPr/>
+          <a:p/>
+        </p:txBody>
       </p:sp>
       <p:sp>
         <p:nvSpPr>
@@ -4201,6 +4293,10 @@
           </a:solidFill>
           <a:ln/>
         </p:spPr>
+        <p:txBody>
+          <a:bodyPr/>
+          <a:p/>
+        </p:txBody>
       </p:sp>
       <p:sp>
         <p:nvSpPr>
@@ -4221,6 +4317,10 @@
           </a:solidFill>
           <a:ln/>
         </p:spPr>
+        <p:txBody>
+          <a:bodyPr/>
+          <a:p/>
+        </p:txBody>
       </p:sp>
       <p:sp>
         <p:nvSpPr>
@@ -4514,6 +4614,10 @@
           </a:solidFill>
           <a:ln/>
         </p:spPr>
+        <p:txBody>
+          <a:bodyPr/>
+          <a:p/>
+        </p:txBody>
       </p:sp>
       <p:sp>
         <p:nvSpPr>
@@ -4575,6 +4679,10 @@
           </a:solidFill>
           <a:ln/>
         </p:spPr>
+        <p:txBody>
+          <a:bodyPr/>
+          <a:p/>
+        </p:txBody>
       </p:sp>
       <p:sp>
         <p:nvSpPr>
@@ -4595,6 +4703,10 @@
           </a:solidFill>
           <a:ln/>
         </p:spPr>
+        <p:txBody>
+          <a:bodyPr/>
+          <a:p/>
+        </p:txBody>
       </p:sp>
       <p:sp>
         <p:nvSpPr>
@@ -4629,7 +4741,7 @@
                 <a:ea typeface="Segoe UI" pitchFamily="34" charset="-122"/>
                 <a:cs typeface="Segoe UI" pitchFamily="34" charset="-120"/>
               </a:rPr>
-              <a:t>AHORRO ANUAL: ~$1.44M USD · 93.7% reducción · ROI en &lt; 1 mes</a:t>
+              <a:t>AHORRO ANUAL: ~$1.44M USD · 93.7% reducción · ROI &lt; 1 mes · IaC con Terraform · Infra inmutable</a:t>
             </a:r>
             <a:endParaRPr lang="en-US" sz="1600" dirty="0"/>
           </a:p>

</xml_diff>

<commit_message>
docs: update all demo documents with current state (May 13, 2026)
- PPTX: node counts (3→2), record counts (20→24), DWS IP, TCO
- Handover markdown: IPs, counts, exposure numbers
- Regenerated PDFs from sources
- Agent Tools section preserved in handover
</commit_message>
<xml_diff>
--- a/docs/ayco-executive-deck.pptx
+++ b/docs/ayco-executive-deck.pptx
@@ -1582,7 +1582,7 @@
                 <a:ea typeface="Segoe UI" pitchFamily="34" charset="-122"/>
                 <a:cs typeface="Segoe UI" pitchFamily="34" charset="-120"/>
               </a:rPr>
-              <a:t>3 nodos · 20 rows</a:t>
+              <a:t>2 nodos · 24 rows</a:t>
             </a:r>
             <a:endParaRPr lang="en-US" sz="1000" dirty="0"/>
           </a:p>
@@ -2500,6 +2500,10 @@
           </a:solidFill>
           <a:ln/>
         </p:spPr>
+        <p:txBody>
+          <a:bodyPr/>
+          <a:p/>
+        </p:txBody>
       </p:sp>
       <p:sp>
         <p:nvSpPr>
@@ -2573,7 +2577,7 @@
                 <a:ea typeface="Segoe UI" pitchFamily="34" charset="-122"/>
                 <a:cs typeface="Segoe UI" pitchFamily="34" charset="-120"/>
               </a:rPr>
-              <a:t>Datos reales · 46.250.161.25:8000 · 20 contratos · Auto-refresh</a:t>
+              <a:t>Datos reales · 46.250.168.254:8000 · 24 contratos · Auto-refresh</a:t>
             </a:r>
             <a:endParaRPr lang="en-US" sz="1300" dirty="0"/>
           </a:p>
@@ -2600,6 +2604,10 @@
           </a:solidFill>
           <a:ln/>
         </p:spPr>
+        <p:txBody>
+          <a:bodyPr/>
+          <a:p/>
+        </p:txBody>
       </p:sp>
       <p:sp>
         <p:nvSpPr>
@@ -2620,6 +2628,10 @@
           </a:solidFill>
           <a:ln/>
         </p:spPr>
+        <p:txBody>
+          <a:bodyPr/>
+          <a:p/>
+        </p:txBody>
       </p:sp>
       <p:sp>
         <p:nvSpPr>
@@ -2759,6 +2771,10 @@
           </a:solidFill>
           <a:ln/>
         </p:spPr>
+        <p:txBody>
+          <a:bodyPr/>
+          <a:p/>
+        </p:txBody>
       </p:sp>
       <p:sp>
         <p:nvSpPr>
@@ -2779,6 +2795,10 @@
           </a:solidFill>
           <a:ln/>
         </p:spPr>
+        <p:txBody>
+          <a:bodyPr/>
+          <a:p/>
+        </p:txBody>
       </p:sp>
       <p:sp>
         <p:nvSpPr>
@@ -2918,6 +2938,10 @@
           </a:solidFill>
           <a:ln/>
         </p:spPr>
+        <p:txBody>
+          <a:bodyPr/>
+          <a:p/>
+        </p:txBody>
       </p:sp>
       <p:sp>
         <p:nvSpPr>
@@ -2938,6 +2962,10 @@
           </a:solidFill>
           <a:ln/>
         </p:spPr>
+        <p:txBody>
+          <a:bodyPr/>
+          <a:p/>
+        </p:txBody>
       </p:sp>
       <p:sp>
         <p:nvSpPr>
@@ -3077,6 +3105,10 @@
           </a:solidFill>
           <a:ln/>
         </p:spPr>
+        <p:txBody>
+          <a:bodyPr/>
+          <a:p/>
+        </p:txBody>
       </p:sp>
       <p:sp>
         <p:nvSpPr>
@@ -3097,6 +3129,10 @@
           </a:solidFill>
           <a:ln/>
         </p:spPr>
+        <p:txBody>
+          <a:bodyPr/>
+          <a:p/>
+        </p:txBody>
       </p:sp>
       <p:sp>
         <p:nvSpPr>
@@ -3234,6 +3270,10 @@
           </a:solidFill>
           <a:ln/>
         </p:spPr>
+        <p:txBody>
+          <a:bodyPr/>
+          <a:p/>
+        </p:txBody>
       </p:sp>
       <p:sp>
         <p:nvSpPr>
@@ -3334,6 +3374,10 @@
           </a:solidFill>
           <a:ln/>
         </p:spPr>
+        <p:txBody>
+          <a:bodyPr/>
+          <a:p/>
+        </p:txBody>
       </p:sp>
       <p:sp>
         <p:nvSpPr>
@@ -3434,6 +3478,10 @@
           </a:solidFill>
           <a:ln/>
         </p:spPr>
+        <p:txBody>
+          <a:bodyPr/>
+          <a:p/>
+        </p:txBody>
       </p:sp>
       <p:sp>
         <p:nvSpPr>
@@ -3534,6 +3582,10 @@
           </a:solidFill>
           <a:ln/>
         </p:spPr>
+        <p:txBody>
+          <a:bodyPr/>
+          <a:p/>
+        </p:txBody>
       </p:sp>
       <p:sp>
         <p:nvSpPr>
@@ -3634,6 +3686,10 @@
           </a:solidFill>
           <a:ln/>
         </p:spPr>
+        <p:txBody>
+          <a:bodyPr/>
+          <a:p/>
+        </p:txBody>
       </p:sp>
       <p:sp>
         <p:nvSpPr>
@@ -4433,7 +4489,7 @@
                 <a:ea typeface="Segoe UI" pitchFamily="34" charset="-122"/>
                 <a:cs typeface="Segoe UI" pitchFamily="34" charset="-120"/>
               </a:rPr>
-              <a:t>+  DWS (3 nodos): ~$280/mes</a:t>
+              <a:t>+  DWS (2 nodos): ~$200/mes</a:t>
             </a:r>
             <a:endParaRPr lang="en-US" sz="1000" dirty="0"/>
           </a:p>
@@ -4652,7 +4708,7 @@
                 <a:ea typeface="Segoe UI" pitchFamily="34" charset="-122"/>
                 <a:cs typeface="Segoe UI" pitchFamily="34" charset="-120"/>
               </a:rPr>
-              <a:t>TOTAL: ~$750 USD / mes (sin DataArts)</a:t>
+              <a:t>TOTAL: ~$670 USD / mes (sin DataArts)</a:t>
             </a:r>
             <a:endParaRPr lang="en-US" sz="1300" dirty="0"/>
           </a:p>

</xml_diff>